<commit_message>
Update Slide 5 ARTIFACTS to Option A layout: top full-width text banner + side-by-side crisp images
</commit_message>
<xml_diff>
--- a/choke_controller_presentation_final.pptx
+++ b/choke_controller_presentation_final.pptx
@@ -5863,7 +5863,7 @@
           </a:lstStyle>
           <a:p>
             <a:pPr>
-              <a:defRPr b="1" sz="2800">
+              <a:defRPr b="1" sz="2600">
                 <a:solidFill>
                   <a:srgbClr val="1D4ED8"/>
                 </a:solidFill>
@@ -5873,13 +5873,6 @@
             <a:r>
               <a:t>AUTONOMOUS CHOKE CONTROLLER FOR AN OIL WELL</a:t>
             </a:r>
-            <a:endParaRPr lang="en-US" b="1" dirty="0">
-              <a:solidFill>
-                <a:schemeClr val="tx1"/>
-              </a:solidFill>
-              <a:latin typeface="Times New Roman" panose="02020603050405020304" pitchFamily="18" charset="0"/>
-              <a:cs typeface="Times New Roman" panose="02020603050405020304" pitchFamily="18" charset="0"/>
-            </a:endParaRPr>
           </a:p>
         </p:txBody>
       </p:sp>
@@ -5915,7 +5908,7 @@
               <a:spcAft>
                 <a:spcPts val="600"/>
               </a:spcAft>
-              <a:defRPr sz="1700">
+              <a:defRPr sz="1600">
                 <a:latin typeface="Arial"/>
               </a:defRPr>
             </a:pPr>
@@ -5929,7 +5922,7 @@
               <a:spcAft>
                 <a:spcPts val="600"/>
               </a:spcAft>
-              <a:defRPr b="1" sz="1700">
+              <a:defRPr b="1" sz="1600">
                 <a:latin typeface="Arial"/>
               </a:defRPr>
             </a:pPr>
@@ -5942,7 +5935,7 @@
               <a:spcAft>
                 <a:spcPts val="600"/>
               </a:spcAft>
-              <a:defRPr sz="1700">
+              <a:defRPr sz="1600">
                 <a:latin typeface="Arial"/>
               </a:defRPr>
             </a:pPr>
@@ -5955,7 +5948,7 @@
               <a:spcAft>
                 <a:spcPts val="1400"/>
               </a:spcAft>
-              <a:defRPr sz="1700">
+              <a:defRPr sz="1600">
                 <a:latin typeface="Arial"/>
               </a:defRPr>
             </a:pPr>
@@ -5968,7 +5961,7 @@
               <a:spcAft>
                 <a:spcPts val="600"/>
               </a:spcAft>
-              <a:defRPr b="1" sz="1700">
+              <a:defRPr b="1" sz="1600">
                 <a:latin typeface="Arial"/>
               </a:defRPr>
             </a:pPr>
@@ -5978,7 +5971,7 @@
           </a:p>
           <a:p>
             <a:pPr>
-              <a:defRPr b="1" sz="1700">
+              <a:defRPr b="1" sz="1600">
                 <a:latin typeface="Arial"/>
               </a:defRPr>
             </a:pPr>
@@ -6038,13 +6031,6 @@
           <a:bodyPr/>
           <a:lstStyle/>
           <a:p>
-            <a:pPr>
-              <a:defRPr b="1">
-                <a:solidFill>
-                  <a:srgbClr val="1D4ED8"/>
-                </a:solidFill>
-              </a:defRPr>
-            </a:pPr>
             <a:r>
               <a:t>PROPOSED SOLUTION</a:t>
             </a:r>
@@ -6061,8 +6047,8 @@
         </p:nvSpPr>
         <p:spPr bwMode="auto">
           <a:xfrm>
-            <a:off x="457200" y="1371600"/>
-            <a:ext cx="5486400" cy="4754880"/>
+            <a:off x="612648" y="1371600"/>
+            <a:ext cx="5303520" cy="4754880"/>
           </a:xfrm>
           <a:prstGeom prst="rect">
             <a:avLst/>
@@ -6083,9 +6069,9 @@
           <a:p>
             <a:pPr>
               <a:spcAft>
-                <a:spcPts val="1000"/>
+                <a:spcPts val="600"/>
               </a:spcAft>
-              <a:defRPr sz="1800" b="1">
+              <a:defRPr sz="1700" b="1">
                 <a:solidFill>
                   <a:srgbClr val="1E293B"/>
                 </a:solidFill>
@@ -6103,9 +6089,9 @@
           <a:p>
             <a:pPr>
               <a:spcAft>
-                <a:spcPts val="600"/>
+                <a:spcPts val="400"/>
               </a:spcAft>
-              <a:defRPr sz="1150">
+              <a:defRPr sz="1100">
                 <a:latin typeface="Arial"/>
               </a:defRPr>
             </a:pPr>
@@ -6116,9 +6102,9 @@
           <a:p>
             <a:pPr>
               <a:spcAft>
-                <a:spcPts val="600"/>
+                <a:spcPts val="400"/>
               </a:spcAft>
-              <a:defRPr sz="1150">
+              <a:defRPr sz="1100">
                 <a:latin typeface="Arial"/>
               </a:defRPr>
             </a:pPr>
@@ -6129,9 +6115,9 @@
           <a:p>
             <a:pPr>
               <a:spcAft>
-                <a:spcPts val="600"/>
+                <a:spcPts val="400"/>
               </a:spcAft>
-              <a:defRPr sz="1150">
+              <a:defRPr sz="1100">
                 <a:latin typeface="Arial"/>
               </a:defRPr>
             </a:pPr>
@@ -6142,9 +6128,9 @@
           <a:p>
             <a:pPr>
               <a:spcAft>
-                <a:spcPts val="600"/>
+                <a:spcPts val="400"/>
               </a:spcAft>
-              <a:defRPr sz="1150">
+              <a:defRPr sz="1100">
                 <a:latin typeface="Arial"/>
               </a:defRPr>
             </a:pPr>
@@ -6155,9 +6141,9 @@
           <a:p>
             <a:pPr>
               <a:spcAft>
-                <a:spcPts val="600"/>
+                <a:spcPts val="400"/>
               </a:spcAft>
-              <a:defRPr sz="1150">
+              <a:defRPr sz="1100">
                 <a:latin typeface="Arial"/>
               </a:defRPr>
             </a:pPr>
@@ -6254,8 +6240,8 @@
         </p:blipFill>
         <p:spPr>
           <a:xfrm>
-            <a:off x="6217920" y="1371600"/>
-            <a:ext cx="5486400" cy="4389120"/>
+            <a:off x="6126480" y="1280160"/>
+            <a:ext cx="5577840" cy="3984171"/>
           </a:xfrm>
           <a:prstGeom prst="rect">
             <a:avLst/>
@@ -6302,15 +6288,8 @@
           <a:bodyPr/>
           <a:lstStyle/>
           <a:p>
-            <a:pPr>
-              <a:defRPr b="1">
-                <a:solidFill>
-                  <a:srgbClr val="1D4ED8"/>
-                </a:solidFill>
-              </a:defRPr>
-            </a:pPr>
-            <a:r>
-              <a:t>TECHNICAL APPROACH &amp; DYNAMIC MODEL</a:t>
+            <a:r>
+              <a:t>TECHNICAL APPROACH</a:t>
             </a:r>
           </a:p>
         </p:txBody>
@@ -6325,8 +6304,8 @@
         </p:nvSpPr>
         <p:spPr bwMode="auto">
           <a:xfrm>
-            <a:off x="457200" y="1371600"/>
-            <a:ext cx="5486400" cy="4754880"/>
+            <a:off x="612648" y="1371600"/>
+            <a:ext cx="5303520" cy="4754880"/>
           </a:xfrm>
           <a:prstGeom prst="rect">
             <a:avLst/>
@@ -6347,11 +6326,11 @@
           <a:p>
             <a:pPr marL="342900" indent="-342900" algn="just">
               <a:spcAft>
-                <a:spcPts val="1000"/>
+                <a:spcPts val="600"/>
               </a:spcAft>
               <a:buFont typeface="Arial" panose="020B0604020202020204" pitchFamily="34" charset="0"/>
               <a:buChar char="•"/>
-              <a:defRPr sz="1800" b="1">
+              <a:defRPr sz="1700" b="1">
                 <a:solidFill>
                   <a:srgbClr val="1E293B"/>
                 </a:solidFill>
@@ -6359,13 +6338,13 @@
               </a:defRPr>
             </a:pPr>
             <a:r>
-              <a:t>ARX System Modeling &amp; Cost Formulation</a:t>
+              <a:t>ARX Dynamic Modeling &amp; Cost Formulation</a:t>
             </a:r>
           </a:p>
           <a:p>
             <a:pPr>
               <a:spcAft>
-                <a:spcPts val="600"/>
+                <a:spcPts val="400"/>
               </a:spcAft>
               <a:defRPr sz="1100">
                 <a:latin typeface="Arial"/>
@@ -6378,7 +6357,7 @@
           <a:p>
             <a:pPr>
               <a:spcAft>
-                <a:spcPts val="600"/>
+                <a:spcPts val="400"/>
               </a:spcAft>
               <a:defRPr sz="1100">
                 <a:latin typeface="Arial"/>
@@ -6391,7 +6370,7 @@
           <a:p>
             <a:pPr>
               <a:spcAft>
-                <a:spcPts val="600"/>
+                <a:spcPts val="400"/>
               </a:spcAft>
               <a:defRPr sz="1100">
                 <a:latin typeface="Arial"/>
@@ -6404,7 +6383,7 @@
           <a:p>
             <a:pPr>
               <a:spcAft>
-                <a:spcPts val="600"/>
+                <a:spcPts val="400"/>
               </a:spcAft>
               <a:defRPr sz="1100">
                 <a:latin typeface="Arial"/>
@@ -6417,7 +6396,7 @@
           <a:p>
             <a:pPr>
               <a:spcAft>
-                <a:spcPts val="600"/>
+                <a:spcPts val="400"/>
               </a:spcAft>
               <a:defRPr sz="1100">
                 <a:latin typeface="Arial"/>
@@ -6430,20 +6409,20 @@
           <a:p>
             <a:pPr>
               <a:spcAft>
-                <a:spcPts val="600"/>
+                <a:spcPts val="400"/>
               </a:spcAft>
               <a:defRPr sz="1100">
                 <a:latin typeface="Arial"/>
               </a:defRPr>
             </a:pPr>
             <a:r>
-              <a:t>• Ramp Rate Enforcement: Enforces maximum valve movement limit of +/- 5% choke opening per hour across the prediction horizon (Hp = 30h).</a:t>
+              <a:t>• Ramp Rate Enforcement: Enforces maximum valve movement limit of +/- 5% choke opening per hour across prediction horizon (Hp = 30h).</a:t>
             </a:r>
           </a:p>
           <a:p>
             <a:pPr>
               <a:spcAft>
-                <a:spcPts val="600"/>
+                <a:spcPts val="400"/>
               </a:spcAft>
               <a:defRPr sz="1100">
                 <a:latin typeface="Arial"/>
@@ -6542,8 +6521,8 @@
         </p:blipFill>
         <p:spPr>
           <a:xfrm>
-            <a:off x="6217920" y="1371600"/>
-            <a:ext cx="5486400" cy="4389120"/>
+            <a:off x="6126480" y="1280160"/>
+            <a:ext cx="5577840" cy="4090416"/>
           </a:xfrm>
           <a:prstGeom prst="rect">
             <a:avLst/>
@@ -6590,15 +6569,8 @@
           <a:bodyPr/>
           <a:lstStyle/>
           <a:p>
-            <a:pPr>
-              <a:defRPr b="1">
-                <a:solidFill>
-                  <a:srgbClr val="1D4ED8"/>
-                </a:solidFill>
-              </a:defRPr>
-            </a:pPr>
-            <a:r>
-              <a:t>FEASIBILITY, VIABILITY &amp; SAFETY</a:t>
+            <a:r>
+              <a:t>FEASIBILITY AND VIABILITY</a:t>
             </a:r>
           </a:p>
         </p:txBody>
@@ -6613,8 +6585,8 @@
         </p:nvSpPr>
         <p:spPr bwMode="auto">
           <a:xfrm>
-            <a:off x="457200" y="1371600"/>
-            <a:ext cx="5486400" cy="4754880"/>
+            <a:off x="612648" y="1371600"/>
+            <a:ext cx="5303520" cy="4754880"/>
           </a:xfrm>
           <a:prstGeom prst="rect">
             <a:avLst/>
@@ -6641,14 +6613,14 @@
                 <a:spcPct val="0"/>
               </a:spcBef>
               <a:spcAft>
-                <a:spcPts val="1000"/>
+                <a:spcPts val="600"/>
               </a:spcAft>
               <a:buClrTx/>
               <a:buSzTx/>
               <a:buFont typeface="Arial" panose="020B0604020202020204" pitchFamily="34" charset="0"/>
               <a:buChar char="•"/>
               <a:tabLst/>
-              <a:defRPr sz="1800" b="1">
+              <a:defRPr sz="1700" b="1">
                 <a:solidFill>
                   <a:srgbClr val="1E293B"/>
                 </a:solidFill>
@@ -6676,9 +6648,9 @@
           <a:p>
             <a:pPr>
               <a:spcAft>
-                <a:spcPts val="600"/>
+                <a:spcPts val="400"/>
               </a:spcAft>
-              <a:defRPr sz="1150">
+              <a:defRPr sz="1100">
                 <a:latin typeface="Arial"/>
               </a:defRPr>
             </a:pPr>
@@ -6689,9 +6661,9 @@
           <a:p>
             <a:pPr>
               <a:spcAft>
-                <a:spcPts val="600"/>
+                <a:spcPts val="400"/>
               </a:spcAft>
-              <a:defRPr sz="1150">
+              <a:defRPr sz="1100">
                 <a:latin typeface="Arial"/>
               </a:defRPr>
             </a:pPr>
@@ -6702,9 +6674,9 @@
           <a:p>
             <a:pPr>
               <a:spcAft>
-                <a:spcPts val="600"/>
+                <a:spcPts val="400"/>
               </a:spcAft>
-              <a:defRPr sz="1150">
+              <a:defRPr sz="1100">
                 <a:latin typeface="Arial"/>
               </a:defRPr>
             </a:pPr>
@@ -6715,9 +6687,9 @@
           <a:p>
             <a:pPr>
               <a:spcAft>
-                <a:spcPts val="600"/>
+                <a:spcPts val="400"/>
               </a:spcAft>
-              <a:defRPr sz="1150">
+              <a:defRPr sz="1100">
                 <a:latin typeface="Arial"/>
               </a:defRPr>
             </a:pPr>
@@ -6897,8 +6869,8 @@
         </p:blipFill>
         <p:spPr>
           <a:xfrm>
-            <a:off x="6217920" y="1371600"/>
-            <a:ext cx="5486400" cy="4389120"/>
+            <a:off x="6126480" y="1280160"/>
+            <a:ext cx="5577840" cy="4090416"/>
           </a:xfrm>
           <a:prstGeom prst="rect">
             <a:avLst/>
@@ -6962,15 +6934,8 @@
           <a:bodyPr/>
           <a:lstStyle/>
           <a:p>
-            <a:pPr>
-              <a:defRPr b="1">
-                <a:solidFill>
-                  <a:srgbClr val="1D4ED8"/>
-                </a:solidFill>
-              </a:defRPr>
-            </a:pPr>
-            <a:r>
-              <a:t>SIMULATION RESULTS &amp; OPERATOR DASHBOARD</a:t>
+            <a:r>
+              <a:t>ARTIFACTS</a:t>
             </a:r>
           </a:p>
         </p:txBody>
@@ -6991,8 +6956,8 @@
         </p:nvSpPr>
         <p:spPr bwMode="auto">
           <a:xfrm>
-            <a:off x="457200" y="1371600"/>
-            <a:ext cx="5486400" cy="4754880"/>
+            <a:off x="612648" y="1143000"/>
+            <a:ext cx="10972800" cy="1645920"/>
           </a:xfrm>
           <a:prstGeom prst="rect">
             <a:avLst/>
@@ -7019,14 +6984,14 @@
                 <a:spcPct val="0"/>
               </a:spcBef>
               <a:spcAft>
-                <a:spcPts val="1000"/>
+                <a:spcPts val="600"/>
               </a:spcAft>
               <a:buClrTx/>
               <a:buSzTx/>
               <a:buFont typeface="Arial" panose="020B0604020202020204" pitchFamily="34" charset="0"/>
               <a:buChar char="•"/>
               <a:tabLst/>
-              <a:defRPr sz="1800" b="1">
+              <a:defRPr sz="1600" b="1">
                 <a:solidFill>
                   <a:srgbClr val="1E293B"/>
                 </a:solidFill>
@@ -7034,59 +6999,46 @@
               </a:defRPr>
             </a:pPr>
             <a:r>
-              <a:t>Demonstrated Performance &amp; Web App</a:t>
+              <a:t>Simulation Results &amp; Web Operator Dashboard</a:t>
             </a:r>
           </a:p>
           <a:p>
             <a:pPr>
               <a:spcAft>
-                <a:spcPts val="600"/>
+                <a:spcPts val="400"/>
               </a:spcAft>
-              <a:defRPr sz="1100">
+              <a:defRPr sz="1050">
                 <a:latin typeface="Arial"/>
               </a:defRPr>
             </a:pPr>
             <a:r>
-              <a:t>• Scenario A (Startup): Ramps choke smoothly at max 5%/hr to reach 120 bbl/hr target with zero violations.</a:t>
+              <a:t>• Scenario C Infeasible Target Analysis: Target = 200 bbl/hr requested. Controller automatically caps choke at 61.9% to maintain BHP &gt;= 2900 psi, settling at maximum safe production of 151.7 bbl/hr.</a:t>
             </a:r>
           </a:p>
           <a:p>
             <a:pPr>
               <a:spcAft>
-                <a:spcPts val="600"/>
+                <a:spcPts val="400"/>
               </a:spcAft>
-              <a:defRPr sz="1100">
+              <a:defRPr sz="1050">
                 <a:latin typeface="Arial"/>
               </a:defRPr>
             </a:pPr>
             <a:r>
-              <a:t>• Scenario B (Tracking): Tracks target step to 150 bbl/hr. Settled choke = 60.9%, flow = 150.0 bbl/hr, BHP = 2931 psi.</a:t>
+              <a:t>• Interactive Web Operator Dashboard: True black UI with animated SVG subsurface schematic, 3-state alarm annunciators, live Chart.js trendlines, and decision log terminal.</a:t>
             </a:r>
           </a:p>
           <a:p>
             <a:pPr>
               <a:spcAft>
-                <a:spcPts val="600"/>
+                <a:spcPts val="400"/>
               </a:spcAft>
-              <a:defRPr sz="1100">
+              <a:defRPr sz="1050">
                 <a:latin typeface="Arial"/>
               </a:defRPr>
             </a:pPr>
             <a:r>
-              <a:t>• Scenario C (Infeasible Target = 200 bbl/hr): Automatically caps choke opening at 61.9% to maintain BHP &gt;= 2900 psi limit, achieving maximum safe production of 151.7 bbl/hr.</a:t>
-            </a:r>
-          </a:p>
-          <a:p>
-            <a:pPr>
-              <a:spcAft>
-                <a:spcPts val="600"/>
-              </a:spcAft>
-              <a:defRPr sz="1100">
-                <a:latin typeface="Arial"/>
-              </a:defRPr>
-            </a:pPr>
-            <a:r>
-              <a:t>• Interactive Web Dashboard: Features a true black UI, animated SVG subsurface well schematic with rising oil bubbles, live Chart.js trends, real-time decision console, and simulation summary analytics.</a:t>
+              <a:t>• Deliverables Package: Complete Python controller scripts, config.json, offline Chart.js web app, presentation deck, and CSV output logs.</a:t>
             </a:r>
           </a:p>
         </p:txBody>
@@ -7259,7 +7211,7 @@
       </p:sp>
       <p:pic>
         <p:nvPicPr>
-          <p:cNvPr id="17411" name="Picture 17410" descr="dashboard_screenshot.png"/>
+          <p:cNvPr id="17411" name="Picture 17410" descr="dashboard_screenshot_formatted.png"/>
           <p:cNvPicPr>
             <a:picLocks noChangeAspect="1"/>
           </p:cNvPicPr>
@@ -7273,8 +7225,32 @@
         </p:blipFill>
         <p:spPr>
           <a:xfrm>
-            <a:off x="6035040" y="1280160"/>
-            <a:ext cx="5760720" cy="4572000"/>
+            <a:off x="612648" y="2926080"/>
+            <a:ext cx="5303520" cy="3383280"/>
+          </a:xfrm>
+          <a:prstGeom prst="rect">
+            <a:avLst/>
+          </a:prstGeom>
+        </p:spPr>
+      </p:pic>
+      <p:pic>
+        <p:nvPicPr>
+          <p:cNvPr id="17412" name="Picture 17411" descr="scenario_c_infeasible.png"/>
+          <p:cNvPicPr>
+            <a:picLocks noChangeAspect="1"/>
+          </p:cNvPicPr>
+          <p:nvPr/>
+        </p:nvPicPr>
+        <p:blipFill>
+          <a:blip r:embed="rId4"/>
+          <a:stretch>
+            <a:fillRect/>
+          </a:stretch>
+        </p:blipFill>
+        <p:spPr>
+          <a:xfrm>
+            <a:off x="6217920" y="2926080"/>
+            <a:ext cx="5303520" cy="3383280"/>
           </a:xfrm>
           <a:prstGeom prst="rect">
             <a:avLst/>
@@ -7326,15 +7302,8 @@
           <a:bodyPr/>
           <a:lstStyle/>
           <a:p>
-            <a:pPr>
-              <a:defRPr b="1">
-                <a:solidFill>
-                  <a:srgbClr val="1D4ED8"/>
-                </a:solidFill>
-              </a:defRPr>
-            </a:pPr>
-            <a:r>
-              <a:t>RESEARCH &amp; REFERENCES</a:t>
+            <a:r>
+              <a:t>RESEARCH  AND REFERENCES</a:t>
             </a:r>
           </a:p>
         </p:txBody>
@@ -7349,8 +7318,8 @@
         </p:nvSpPr>
         <p:spPr bwMode="auto">
           <a:xfrm>
-            <a:off x="457200" y="1371600"/>
-            <a:ext cx="11274552" cy="4754880"/>
+            <a:off x="612648" y="1371600"/>
+            <a:ext cx="10972800" cy="4754880"/>
           </a:xfrm>
           <a:prstGeom prst="rect">
             <a:avLst/>
@@ -7377,14 +7346,14 @@
                 <a:spcPct val="0"/>
               </a:spcBef>
               <a:spcAft>
-                <a:spcPts val="1000"/>
+                <a:spcPts val="600"/>
               </a:spcAft>
               <a:buClrTx/>
               <a:buSzTx/>
               <a:buFont typeface="Arial" panose="020B0604020202020204" pitchFamily="34" charset="0"/>
               <a:buChar char="•"/>
               <a:tabLst/>
-              <a:defRPr sz="2000" b="1">
+              <a:defRPr sz="1800" b="1">
                 <a:solidFill>
                   <a:srgbClr val="1E293B"/>
                 </a:solidFill>
@@ -7412,9 +7381,9 @@
           <a:p>
             <a:pPr>
               <a:spcAft>
-                <a:spcPts val="600"/>
+                <a:spcPts val="400"/>
               </a:spcAft>
-              <a:defRPr sz="1100">
+              <a:defRPr sz="1050">
                 <a:latin typeface="Arial"/>
               </a:defRPr>
             </a:pPr>
@@ -7429,9 +7398,9 @@
           <a:p>
             <a:pPr>
               <a:spcAft>
-                <a:spcPts val="600"/>
+                <a:spcPts val="400"/>
               </a:spcAft>
-              <a:defRPr sz="1100">
+              <a:defRPr sz="1050">
                 <a:latin typeface="Arial"/>
               </a:defRPr>
             </a:pPr>
@@ -7446,9 +7415,9 @@
           <a:p>
             <a:pPr>
               <a:spcAft>
-                <a:spcPts val="600"/>
+                <a:spcPts val="400"/>
               </a:spcAft>
-              <a:defRPr sz="1100">
+              <a:defRPr sz="1050">
                 <a:latin typeface="Arial"/>
               </a:defRPr>
             </a:pPr>
@@ -7463,9 +7432,9 @@
           <a:p>
             <a:pPr>
               <a:spcAft>
-                <a:spcPts val="600"/>
+                <a:spcPts val="400"/>
               </a:spcAft>
-              <a:defRPr sz="1100">
+              <a:defRPr sz="1050">
                 <a:latin typeface="Arial"/>
               </a:defRPr>
             </a:pPr>
@@ -7480,9 +7449,9 @@
           <a:p>
             <a:pPr>
               <a:spcAft>
-                <a:spcPts val="600"/>
+                <a:spcPts val="400"/>
               </a:spcAft>
-              <a:defRPr sz="1100">
+              <a:defRPr sz="1050">
                 <a:latin typeface="Arial"/>
               </a:defRPr>
             </a:pPr>

</xml_diff>

<commit_message>
Eliminate Slide 5 whitespace: move images up to top 2.25in and expand dimensions to 5.9x4.6in
</commit_message>
<xml_diff>
--- a/choke_controller_presentation_final.pptx
+++ b/choke_controller_presentation_final.pptx
@@ -6069,7 +6069,7 @@
           <a:p>
             <a:pPr>
               <a:spcAft>
-                <a:spcPts val="600"/>
+                <a:spcPts val="400"/>
               </a:spcAft>
               <a:defRPr sz="1700" b="1">
                 <a:solidFill>
@@ -6089,7 +6089,7 @@
           <a:p>
             <a:pPr>
               <a:spcAft>
-                <a:spcPts val="400"/>
+                <a:spcPts val="300"/>
               </a:spcAft>
               <a:defRPr sz="1100">
                 <a:latin typeface="Arial"/>
@@ -6102,7 +6102,7 @@
           <a:p>
             <a:pPr>
               <a:spcAft>
-                <a:spcPts val="400"/>
+                <a:spcPts val="300"/>
               </a:spcAft>
               <a:defRPr sz="1100">
                 <a:latin typeface="Arial"/>
@@ -6115,7 +6115,7 @@
           <a:p>
             <a:pPr>
               <a:spcAft>
-                <a:spcPts val="400"/>
+                <a:spcPts val="300"/>
               </a:spcAft>
               <a:defRPr sz="1100">
                 <a:latin typeface="Arial"/>
@@ -6128,7 +6128,7 @@
           <a:p>
             <a:pPr>
               <a:spcAft>
-                <a:spcPts val="400"/>
+                <a:spcPts val="300"/>
               </a:spcAft>
               <a:defRPr sz="1100">
                 <a:latin typeface="Arial"/>
@@ -6141,7 +6141,7 @@
           <a:p>
             <a:pPr>
               <a:spcAft>
-                <a:spcPts val="400"/>
+                <a:spcPts val="300"/>
               </a:spcAft>
               <a:defRPr sz="1100">
                 <a:latin typeface="Arial"/>
@@ -6326,7 +6326,7 @@
           <a:p>
             <a:pPr marL="342900" indent="-342900" algn="just">
               <a:spcAft>
-                <a:spcPts val="600"/>
+                <a:spcPts val="400"/>
               </a:spcAft>
               <a:buFont typeface="Arial" panose="020B0604020202020204" pitchFamily="34" charset="0"/>
               <a:buChar char="•"/>
@@ -6344,7 +6344,7 @@
           <a:p>
             <a:pPr>
               <a:spcAft>
-                <a:spcPts val="400"/>
+                <a:spcPts val="300"/>
               </a:spcAft>
               <a:defRPr sz="1100">
                 <a:latin typeface="Arial"/>
@@ -6357,7 +6357,7 @@
           <a:p>
             <a:pPr>
               <a:spcAft>
-                <a:spcPts val="400"/>
+                <a:spcPts val="300"/>
               </a:spcAft>
               <a:defRPr sz="1100">
                 <a:latin typeface="Arial"/>
@@ -6370,7 +6370,7 @@
           <a:p>
             <a:pPr>
               <a:spcAft>
-                <a:spcPts val="400"/>
+                <a:spcPts val="300"/>
               </a:spcAft>
               <a:defRPr sz="1100">
                 <a:latin typeface="Arial"/>
@@ -6383,7 +6383,7 @@
           <a:p>
             <a:pPr>
               <a:spcAft>
-                <a:spcPts val="400"/>
+                <a:spcPts val="300"/>
               </a:spcAft>
               <a:defRPr sz="1100">
                 <a:latin typeface="Arial"/>
@@ -6396,7 +6396,7 @@
           <a:p>
             <a:pPr>
               <a:spcAft>
-                <a:spcPts val="400"/>
+                <a:spcPts val="300"/>
               </a:spcAft>
               <a:defRPr sz="1100">
                 <a:latin typeface="Arial"/>
@@ -6409,7 +6409,7 @@
           <a:p>
             <a:pPr>
               <a:spcAft>
-                <a:spcPts val="400"/>
+                <a:spcPts val="300"/>
               </a:spcAft>
               <a:defRPr sz="1100">
                 <a:latin typeface="Arial"/>
@@ -6422,7 +6422,7 @@
           <a:p>
             <a:pPr>
               <a:spcAft>
-                <a:spcPts val="400"/>
+                <a:spcPts val="300"/>
               </a:spcAft>
               <a:defRPr sz="1100">
                 <a:latin typeface="Arial"/>
@@ -6613,7 +6613,7 @@
                 <a:spcPct val="0"/>
               </a:spcBef>
               <a:spcAft>
-                <a:spcPts val="600"/>
+                <a:spcPts val="400"/>
               </a:spcAft>
               <a:buClrTx/>
               <a:buSzTx/>
@@ -6648,7 +6648,7 @@
           <a:p>
             <a:pPr>
               <a:spcAft>
-                <a:spcPts val="400"/>
+                <a:spcPts val="300"/>
               </a:spcAft>
               <a:defRPr sz="1100">
                 <a:latin typeface="Arial"/>
@@ -6661,7 +6661,7 @@
           <a:p>
             <a:pPr>
               <a:spcAft>
-                <a:spcPts val="400"/>
+                <a:spcPts val="300"/>
               </a:spcAft>
               <a:defRPr sz="1100">
                 <a:latin typeface="Arial"/>
@@ -6674,7 +6674,7 @@
           <a:p>
             <a:pPr>
               <a:spcAft>
-                <a:spcPts val="400"/>
+                <a:spcPts val="300"/>
               </a:spcAft>
               <a:defRPr sz="1100">
                 <a:latin typeface="Arial"/>
@@ -6687,7 +6687,7 @@
           <a:p>
             <a:pPr>
               <a:spcAft>
-                <a:spcPts val="400"/>
+                <a:spcPts val="300"/>
               </a:spcAft>
               <a:defRPr sz="1100">
                 <a:latin typeface="Arial"/>
@@ -6956,8 +6956,8 @@
         </p:nvSpPr>
         <p:spPr bwMode="auto">
           <a:xfrm>
-            <a:off x="612648" y="1143000"/>
-            <a:ext cx="10972800" cy="1645920"/>
+            <a:off x="612648" y="1051560"/>
+            <a:ext cx="10972800" cy="914400"/>
           </a:xfrm>
           <a:prstGeom prst="rect">
             <a:avLst/>
@@ -6984,14 +6984,14 @@
                 <a:spcPct val="0"/>
               </a:spcBef>
               <a:spcAft>
-                <a:spcPts val="600"/>
+                <a:spcPts val="400"/>
               </a:spcAft>
               <a:buClrTx/>
               <a:buSzTx/>
               <a:buFont typeface="Arial" panose="020B0604020202020204" pitchFamily="34" charset="0"/>
               <a:buChar char="•"/>
               <a:tabLst/>
-              <a:defRPr sz="1600" b="1">
+              <a:defRPr sz="1500" b="1">
                 <a:solidFill>
                   <a:srgbClr val="1E293B"/>
                 </a:solidFill>
@@ -7005,40 +7005,40 @@
           <a:p>
             <a:pPr>
               <a:spcAft>
-                <a:spcPts val="400"/>
+                <a:spcPts val="300"/>
               </a:spcAft>
-              <a:defRPr sz="1050">
+              <a:defRPr sz="1000">
                 <a:latin typeface="Arial"/>
               </a:defRPr>
             </a:pPr>
             <a:r>
-              <a:t>• Scenario C Infeasible Target Analysis: Target = 200 bbl/hr requested. Controller automatically caps choke at 61.9% to maintain BHP &gt;= 2900 psi, settling at maximum safe production of 151.7 bbl/hr.</a:t>
+              <a:t>• Scenario C Infeasible Target Analysis: Requested Target = 200 bbl/hr. Controller caps choke at 61.9% to maintain BHP &gt;= 2900 psi limit, achieving max safe rate of 151.7 bbl/hr.</a:t>
             </a:r>
           </a:p>
           <a:p>
             <a:pPr>
               <a:spcAft>
-                <a:spcPts val="400"/>
+                <a:spcPts val="300"/>
               </a:spcAft>
-              <a:defRPr sz="1050">
+              <a:defRPr sz="1000">
                 <a:latin typeface="Arial"/>
               </a:defRPr>
             </a:pPr>
             <a:r>
-              <a:t>• Interactive Web Operator Dashboard: True black UI with animated SVG subsurface schematic, 3-state alarm annunciators, live Chart.js trendlines, and decision log terminal.</a:t>
+              <a:t>• Interactive Web Operator Dashboard: True black DCS UI with animated SVG wellhead, 3-state alarm annunciators, live Chart.js trendlines, and decision log terminal.</a:t>
             </a:r>
           </a:p>
           <a:p>
             <a:pPr>
               <a:spcAft>
-                <a:spcPts val="400"/>
+                <a:spcPts val="300"/>
               </a:spcAft>
-              <a:defRPr sz="1050">
+              <a:defRPr sz="1000">
                 <a:latin typeface="Arial"/>
               </a:defRPr>
             </a:pPr>
             <a:r>
-              <a:t>• Deliverables Package: Complete Python controller scripts, config.json, offline Chart.js web app, presentation deck, and CSV output logs.</a:t>
+              <a:t>• Software &amp; Hardware Deliverables: Complete Python control code, offline Chart.js web app, presentation deck, and CSV output logs.</a:t>
             </a:r>
           </a:p>
         </p:txBody>
@@ -7225,8 +7225,8 @@
         </p:blipFill>
         <p:spPr>
           <a:xfrm>
-            <a:off x="612648" y="2926080"/>
-            <a:ext cx="5303520" cy="3383280"/>
+            <a:off x="612648" y="2057400"/>
+            <a:ext cx="5394960" cy="4206240"/>
           </a:xfrm>
           <a:prstGeom prst="rect">
             <a:avLst/>
@@ -7249,8 +7249,8 @@
         </p:blipFill>
         <p:spPr>
           <a:xfrm>
-            <a:off x="6217920" y="2926080"/>
-            <a:ext cx="5303520" cy="3383280"/>
+            <a:off x="6172200" y="2057400"/>
+            <a:ext cx="5394960" cy="4206240"/>
           </a:xfrm>
           <a:prstGeom prst="rect">
             <a:avLst/>
@@ -7346,7 +7346,7 @@
                 <a:spcPct val="0"/>
               </a:spcBef>
               <a:spcAft>
-                <a:spcPts val="600"/>
+                <a:spcPts val="400"/>
               </a:spcAft>
               <a:buClrTx/>
               <a:buSzTx/>
@@ -7381,7 +7381,7 @@
           <a:p>
             <a:pPr>
               <a:spcAft>
-                <a:spcPts val="400"/>
+                <a:spcPts val="300"/>
               </a:spcAft>
               <a:defRPr sz="1050">
                 <a:latin typeface="Arial"/>
@@ -7398,7 +7398,7 @@
           <a:p>
             <a:pPr>
               <a:spcAft>
-                <a:spcPts val="400"/>
+                <a:spcPts val="300"/>
               </a:spcAft>
               <a:defRPr sz="1050">
                 <a:latin typeface="Arial"/>
@@ -7415,7 +7415,7 @@
           <a:p>
             <a:pPr>
               <a:spcAft>
-                <a:spcPts val="400"/>
+                <a:spcPts val="300"/>
               </a:spcAft>
               <a:defRPr sz="1050">
                 <a:latin typeface="Arial"/>
@@ -7432,7 +7432,7 @@
           <a:p>
             <a:pPr>
               <a:spcAft>
-                <a:spcPts val="400"/>
+                <a:spcPts val="300"/>
               </a:spcAft>
               <a:defRPr sz="1050">
                 <a:latin typeface="Arial"/>
@@ -7449,7 +7449,7 @@
           <a:p>
             <a:pPr>
               <a:spcAft>
-                <a:spcPts val="400"/>
+                <a:spcPts val="300"/>
               </a:spcAft>
               <a:defRPr sz="1050">
                 <a:latin typeface="Arial"/>

</xml_diff>

<commit_message>
Update Slide 5 ARTIFACTS text banner to include explicit summaries of Scenarios A, B, C, and Web Operator Dashboard
</commit_message>
<xml_diff>
--- a/choke_controller_presentation_final.pptx
+++ b/choke_controller_presentation_final.pptx
@@ -6069,7 +6069,7 @@
           <a:p>
             <a:pPr>
               <a:spcAft>
-                <a:spcPts val="400"/>
+                <a:spcPts val="300"/>
               </a:spcAft>
               <a:defRPr sz="1700" b="1">
                 <a:solidFill>
@@ -6089,7 +6089,7 @@
           <a:p>
             <a:pPr>
               <a:spcAft>
-                <a:spcPts val="300"/>
+                <a:spcPts val="200"/>
               </a:spcAft>
               <a:defRPr sz="1100">
                 <a:latin typeface="Arial"/>
@@ -6102,7 +6102,7 @@
           <a:p>
             <a:pPr>
               <a:spcAft>
-                <a:spcPts val="300"/>
+                <a:spcPts val="200"/>
               </a:spcAft>
               <a:defRPr sz="1100">
                 <a:latin typeface="Arial"/>
@@ -6115,7 +6115,7 @@
           <a:p>
             <a:pPr>
               <a:spcAft>
-                <a:spcPts val="300"/>
+                <a:spcPts val="200"/>
               </a:spcAft>
               <a:defRPr sz="1100">
                 <a:latin typeface="Arial"/>
@@ -6128,7 +6128,7 @@
           <a:p>
             <a:pPr>
               <a:spcAft>
-                <a:spcPts val="300"/>
+                <a:spcPts val="200"/>
               </a:spcAft>
               <a:defRPr sz="1100">
                 <a:latin typeface="Arial"/>
@@ -6141,7 +6141,7 @@
           <a:p>
             <a:pPr>
               <a:spcAft>
-                <a:spcPts val="300"/>
+                <a:spcPts val="200"/>
               </a:spcAft>
               <a:defRPr sz="1100">
                 <a:latin typeface="Arial"/>
@@ -6326,7 +6326,7 @@
           <a:p>
             <a:pPr marL="342900" indent="-342900" algn="just">
               <a:spcAft>
-                <a:spcPts val="400"/>
+                <a:spcPts val="300"/>
               </a:spcAft>
               <a:buFont typeface="Arial" panose="020B0604020202020204" pitchFamily="34" charset="0"/>
               <a:buChar char="•"/>
@@ -6344,7 +6344,7 @@
           <a:p>
             <a:pPr>
               <a:spcAft>
-                <a:spcPts val="300"/>
+                <a:spcPts val="200"/>
               </a:spcAft>
               <a:defRPr sz="1100">
                 <a:latin typeface="Arial"/>
@@ -6357,7 +6357,7 @@
           <a:p>
             <a:pPr>
               <a:spcAft>
-                <a:spcPts val="300"/>
+                <a:spcPts val="200"/>
               </a:spcAft>
               <a:defRPr sz="1100">
                 <a:latin typeface="Arial"/>
@@ -6370,7 +6370,7 @@
           <a:p>
             <a:pPr>
               <a:spcAft>
-                <a:spcPts val="300"/>
+                <a:spcPts val="200"/>
               </a:spcAft>
               <a:defRPr sz="1100">
                 <a:latin typeface="Arial"/>
@@ -6383,7 +6383,7 @@
           <a:p>
             <a:pPr>
               <a:spcAft>
-                <a:spcPts val="300"/>
+                <a:spcPts val="200"/>
               </a:spcAft>
               <a:defRPr sz="1100">
                 <a:latin typeface="Arial"/>
@@ -6396,7 +6396,7 @@
           <a:p>
             <a:pPr>
               <a:spcAft>
-                <a:spcPts val="300"/>
+                <a:spcPts val="200"/>
               </a:spcAft>
               <a:defRPr sz="1100">
                 <a:latin typeface="Arial"/>
@@ -6409,7 +6409,7 @@
           <a:p>
             <a:pPr>
               <a:spcAft>
-                <a:spcPts val="300"/>
+                <a:spcPts val="200"/>
               </a:spcAft>
               <a:defRPr sz="1100">
                 <a:latin typeface="Arial"/>
@@ -6422,7 +6422,7 @@
           <a:p>
             <a:pPr>
               <a:spcAft>
-                <a:spcPts val="300"/>
+                <a:spcPts val="200"/>
               </a:spcAft>
               <a:defRPr sz="1100">
                 <a:latin typeface="Arial"/>
@@ -6613,7 +6613,7 @@
                 <a:spcPct val="0"/>
               </a:spcBef>
               <a:spcAft>
-                <a:spcPts val="400"/>
+                <a:spcPts val="300"/>
               </a:spcAft>
               <a:buClrTx/>
               <a:buSzTx/>
@@ -6648,7 +6648,7 @@
           <a:p>
             <a:pPr>
               <a:spcAft>
-                <a:spcPts val="300"/>
+                <a:spcPts val="200"/>
               </a:spcAft>
               <a:defRPr sz="1100">
                 <a:latin typeface="Arial"/>
@@ -6661,7 +6661,7 @@
           <a:p>
             <a:pPr>
               <a:spcAft>
-                <a:spcPts val="300"/>
+                <a:spcPts val="200"/>
               </a:spcAft>
               <a:defRPr sz="1100">
                 <a:latin typeface="Arial"/>
@@ -6674,7 +6674,7 @@
           <a:p>
             <a:pPr>
               <a:spcAft>
-                <a:spcPts val="300"/>
+                <a:spcPts val="200"/>
               </a:spcAft>
               <a:defRPr sz="1100">
                 <a:latin typeface="Arial"/>
@@ -6687,7 +6687,7 @@
           <a:p>
             <a:pPr>
               <a:spcAft>
-                <a:spcPts val="300"/>
+                <a:spcPts val="200"/>
               </a:spcAft>
               <a:defRPr sz="1100">
                 <a:latin typeface="Arial"/>
@@ -6956,8 +6956,8 @@
         </p:nvSpPr>
         <p:spPr bwMode="auto">
           <a:xfrm>
-            <a:off x="612648" y="1051560"/>
-            <a:ext cx="10972800" cy="914400"/>
+            <a:off x="612648" y="960120"/>
+            <a:ext cx="10972800" cy="1051560"/>
           </a:xfrm>
           <a:prstGeom prst="rect">
             <a:avLst/>
@@ -6984,7 +6984,7 @@
                 <a:spcPct val="0"/>
               </a:spcBef>
               <a:spcAft>
-                <a:spcPts val="400"/>
+                <a:spcPts val="300"/>
               </a:spcAft>
               <a:buClrTx/>
               <a:buSzTx/>
@@ -6999,46 +6999,59 @@
               </a:defRPr>
             </a:pPr>
             <a:r>
-              <a:t>Simulation Results &amp; Web Operator Dashboard</a:t>
+              <a:t>Control Scenarios Summary &amp; Web Operator Dashboard</a:t>
             </a:r>
           </a:p>
           <a:p>
             <a:pPr>
               <a:spcAft>
-                <a:spcPts val="300"/>
+                <a:spcPts val="200"/>
               </a:spcAft>
-              <a:defRPr sz="1000">
+              <a:defRPr sz="950">
                 <a:latin typeface="Arial"/>
               </a:defRPr>
             </a:pPr>
             <a:r>
-              <a:t>• Scenario C Infeasible Target Analysis: Requested Target = 200 bbl/hr. Controller caps choke at 61.9% to maintain BHP &gt;= 2900 psi limit, achieving max safe rate of 151.7 bbl/hr.</a:t>
+              <a:t>• Scenario A (Startup): Smooth choke ramp at max 5%/hr to reach 120 bbl/hr target with zero violations.</a:t>
             </a:r>
           </a:p>
           <a:p>
             <a:pPr>
               <a:spcAft>
-                <a:spcPts val="300"/>
+                <a:spcPts val="200"/>
               </a:spcAft>
-              <a:defRPr sz="1000">
+              <a:defRPr sz="950">
                 <a:latin typeface="Arial"/>
               </a:defRPr>
             </a:pPr>
             <a:r>
-              <a:t>• Interactive Web Operator Dashboard: True black DCS UI with animated SVG wellhead, 3-state alarm annunciators, live Chart.js trendlines, and decision log terminal.</a:t>
+              <a:t>• Scenario B (Tracking): Step target to 150 bbl/hr. Settled choke = 60.9%, flow = 150.0 bbl/hr, BHP = 2931 psi.</a:t>
             </a:r>
           </a:p>
           <a:p>
             <a:pPr>
               <a:spcAft>
-                <a:spcPts val="300"/>
+                <a:spcPts val="200"/>
               </a:spcAft>
-              <a:defRPr sz="1000">
+              <a:defRPr sz="950">
                 <a:latin typeface="Arial"/>
               </a:defRPr>
             </a:pPr>
             <a:r>
-              <a:t>• Software &amp; Hardware Deliverables: Complete Python control code, offline Chart.js web app, presentation deck, and CSV output logs.</a:t>
+              <a:t>• Scenario C (Infeasible Target = 200 bbl/hr): Automatically caps choke at 61.9% to maintain BHP &gt;= 2900 psi limit, achieving max safe production of 151.7 bbl/hr.</a:t>
+            </a:r>
+          </a:p>
+          <a:p>
+            <a:pPr>
+              <a:spcAft>
+                <a:spcPts val="200"/>
+              </a:spcAft>
+              <a:defRPr sz="950">
+                <a:latin typeface="Arial"/>
+              </a:defRPr>
+            </a:pPr>
+            <a:r>
+              <a:t>• Interactive Web Dashboard &amp; Deliverables: True black DCS UI with animated SVG schematic, 3-state alarms, live Chart.js trendlines, Python scripts, and CSV logs.</a:t>
             </a:r>
           </a:p>
         </p:txBody>
@@ -7346,7 +7359,7 @@
                 <a:spcPct val="0"/>
               </a:spcBef>
               <a:spcAft>
-                <a:spcPts val="400"/>
+                <a:spcPts val="300"/>
               </a:spcAft>
               <a:buClrTx/>
               <a:buSzTx/>
@@ -7381,7 +7394,7 @@
           <a:p>
             <a:pPr>
               <a:spcAft>
-                <a:spcPts val="300"/>
+                <a:spcPts val="200"/>
               </a:spcAft>
               <a:defRPr sz="1050">
                 <a:latin typeface="Arial"/>
@@ -7398,7 +7411,7 @@
           <a:p>
             <a:pPr>
               <a:spcAft>
-                <a:spcPts val="300"/>
+                <a:spcPts val="200"/>
               </a:spcAft>
               <a:defRPr sz="1050">
                 <a:latin typeface="Arial"/>
@@ -7415,7 +7428,7 @@
           <a:p>
             <a:pPr>
               <a:spcAft>
-                <a:spcPts val="300"/>
+                <a:spcPts val="200"/>
               </a:spcAft>
               <a:defRPr sz="1050">
                 <a:latin typeface="Arial"/>
@@ -7432,7 +7445,7 @@
           <a:p>
             <a:pPr>
               <a:spcAft>
-                <a:spcPts val="300"/>
+                <a:spcPts val="200"/>
               </a:spcAft>
               <a:defRPr sz="1050">
                 <a:latin typeface="Arial"/>
@@ -7449,7 +7462,7 @@
           <a:p>
             <a:pPr>
               <a:spcAft>
-                <a:spcPts val="300"/>
+                <a:spcPts val="200"/>
               </a:spcAft>
               <a:defRPr sz="1050">
                 <a:latin typeface="Arial"/>

</xml_diff>